<commit_message>
Adding new examples for v6.3
</commit_message>
<xml_diff>
--- a/parameter-visualisation/parameter_visualisation.pptx
+++ b/parameter-visualisation/parameter_visualisation.pptx
@@ -19607,7 +19607,7 @@
           <a:p>
             <a:fld id="{830D4AAE-87F1-49BA-A98E-415997C9383F}" type="datetimeFigureOut">
               <a:rPr lang="en-AU" smtClean="0"/>
-              <a:t>20/04/2026</a:t>
+              <a:t>22/04/2026</a:t>
             </a:fld>
             <a:endParaRPr lang="en-AU"/>
           </a:p>
@@ -19807,7 +19807,7 @@
           <a:p>
             <a:fld id="{830D4AAE-87F1-49BA-A98E-415997C9383F}" type="datetimeFigureOut">
               <a:rPr lang="en-AU" smtClean="0"/>
-              <a:t>20/04/2026</a:t>
+              <a:t>22/04/2026</a:t>
             </a:fld>
             <a:endParaRPr lang="en-AU"/>
           </a:p>
@@ -20017,7 +20017,7 @@
           <a:p>
             <a:fld id="{830D4AAE-87F1-49BA-A98E-415997C9383F}" type="datetimeFigureOut">
               <a:rPr lang="en-AU" smtClean="0"/>
-              <a:t>20/04/2026</a:t>
+              <a:t>22/04/2026</a:t>
             </a:fld>
             <a:endParaRPr lang="en-AU"/>
           </a:p>
@@ -20217,7 +20217,7 @@
           <a:p>
             <a:fld id="{830D4AAE-87F1-49BA-A98E-415997C9383F}" type="datetimeFigureOut">
               <a:rPr lang="en-AU" smtClean="0"/>
-              <a:t>20/04/2026</a:t>
+              <a:t>22/04/2026</a:t>
             </a:fld>
             <a:endParaRPr lang="en-AU"/>
           </a:p>
@@ -20493,7 +20493,7 @@
           <a:p>
             <a:fld id="{830D4AAE-87F1-49BA-A98E-415997C9383F}" type="datetimeFigureOut">
               <a:rPr lang="en-AU" smtClean="0"/>
-              <a:t>20/04/2026</a:t>
+              <a:t>22/04/2026</a:t>
             </a:fld>
             <a:endParaRPr lang="en-AU"/>
           </a:p>
@@ -20761,7 +20761,7 @@
           <a:p>
             <a:fld id="{830D4AAE-87F1-49BA-A98E-415997C9383F}" type="datetimeFigureOut">
               <a:rPr lang="en-AU" smtClean="0"/>
-              <a:t>20/04/2026</a:t>
+              <a:t>22/04/2026</a:t>
             </a:fld>
             <a:endParaRPr lang="en-AU"/>
           </a:p>
@@ -21176,7 +21176,7 @@
           <a:p>
             <a:fld id="{830D4AAE-87F1-49BA-A98E-415997C9383F}" type="datetimeFigureOut">
               <a:rPr lang="en-AU" smtClean="0"/>
-              <a:t>20/04/2026</a:t>
+              <a:t>22/04/2026</a:t>
             </a:fld>
             <a:endParaRPr lang="en-AU"/>
           </a:p>
@@ -21318,7 +21318,7 @@
           <a:p>
             <a:fld id="{830D4AAE-87F1-49BA-A98E-415997C9383F}" type="datetimeFigureOut">
               <a:rPr lang="en-AU" smtClean="0"/>
-              <a:t>20/04/2026</a:t>
+              <a:t>22/04/2026</a:t>
             </a:fld>
             <a:endParaRPr lang="en-AU"/>
           </a:p>
@@ -21431,7 +21431,7 @@
           <a:p>
             <a:fld id="{830D4AAE-87F1-49BA-A98E-415997C9383F}" type="datetimeFigureOut">
               <a:rPr lang="en-AU" smtClean="0"/>
-              <a:t>20/04/2026</a:t>
+              <a:t>22/04/2026</a:t>
             </a:fld>
             <a:endParaRPr lang="en-AU"/>
           </a:p>
@@ -21744,7 +21744,7 @@
           <a:p>
             <a:fld id="{830D4AAE-87F1-49BA-A98E-415997C9383F}" type="datetimeFigureOut">
               <a:rPr lang="en-AU" smtClean="0"/>
-              <a:t>20/04/2026</a:t>
+              <a:t>22/04/2026</a:t>
             </a:fld>
             <a:endParaRPr lang="en-AU"/>
           </a:p>
@@ -22033,7 +22033,7 @@
           <a:p>
             <a:fld id="{830D4AAE-87F1-49BA-A98E-415997C9383F}" type="datetimeFigureOut">
               <a:rPr lang="en-AU" smtClean="0"/>
-              <a:t>20/04/2026</a:t>
+              <a:t>22/04/2026</a:t>
             </a:fld>
             <a:endParaRPr lang="en-AU"/>
           </a:p>
@@ -22276,7 +22276,7 @@
           <a:p>
             <a:fld id="{830D4AAE-87F1-49BA-A98E-415997C9383F}" type="datetimeFigureOut">
               <a:rPr lang="en-AU" smtClean="0"/>
-              <a:t>20/04/2026</a:t>
+              <a:t>22/04/2026</a:t>
             </a:fld>
             <a:endParaRPr lang="en-AU"/>
           </a:p>

</xml_diff>